<commit_message>
Ensure Introduction, Literature Review, and Bibliography or References slides are explicitly structured in 25MSM40018_Akhilesh.pptx
</commit_message>
<xml_diff>
--- a/MST1/25MSM40018_Akhilesh.pptx
+++ b/MST1/25MSM40018_Akhilesh.pptx
@@ -15,6 +15,7 @@
   <p:sldIdLst>
     <p:sldId id="277" r:id="rId4"/>
     <p:sldId id="400" r:id="rId5"/>
+    <p:sldId id="424" r:id="rId20"/>
     <p:sldId id="408" r:id="rId6"/>
     <p:sldId id="401" r:id="rId7"/>
     <p:sldId id="409" r:id="rId8"/>
@@ -13304,12 +13305,16 @@
           <a:bodyPr/>
           <a:lstStyle/>
           <a:p>
-            <a:fld id="{BDCDBBEF-AA6C-4BA6-85B2-A17D7F280E38}" type="slidenum">
-              <a:rPr lang="en-US" smtClean="0"/>
-              <a:pPr/>
+            <a:pPr algn="r"/>
+            <a:r>
+              <a:rPr sz="1200" b="0" i="0">
+                <a:solidFill>
+                  <a:srgbClr val="787878"/>
+                </a:solidFill>
+                <a:latin typeface="Calibri"/>
+              </a:rPr>
               <a:t>1</a:t>
-            </a:fld>
-            <a:endParaRPr lang="en-US" dirty="0"/>
+            </a:r>
           </a:p>
         </p:txBody>
       </p:sp>
@@ -13595,12 +13600,16 @@
           <a:bodyPr/>
           <a:lstStyle/>
           <a:p>
-            <a:fld id="{BDCDBBEF-AA6C-4BA6-85B2-A17D7F280E38}" type="slidenum">
-              <a:rPr lang="en-US" smtClean="0"/>
-              <a:pPr/>
-              <a:t>10</a:t>
-            </a:fld>
-            <a:endParaRPr lang="en-US" dirty="0"/>
+            <a:pPr algn="r"/>
+            <a:r>
+              <a:rPr sz="1200" b="0" i="0">
+                <a:solidFill>
+                  <a:srgbClr val="787878"/>
+                </a:solidFill>
+                <a:latin typeface="Calibri"/>
+              </a:rPr>
+              <a:t>11</a:t>
+            </a:r>
           </a:p>
         </p:txBody>
       </p:sp>
@@ -13629,6 +13638,228 @@
 </p:sld>
 </file>
 
+<file path=ppt/slides/slide11.xml><?xml version="1.0" encoding="utf-8"?>
+<p:sld xmlns:a="http://schemas.openxmlformats.org/drawingml/2006/main" xmlns:p="http://schemas.openxmlformats.org/presentationml/2006/main" xmlns:r="http://schemas.openxmlformats.org/officeDocument/2006/relationships">
+  <p:cSld>
+    <p:spTree>
+      <p:nvGrpSpPr>
+        <p:cNvPr id="1" name=""/>
+        <p:cNvGrpSpPr/>
+        <p:nvPr/>
+      </p:nvGrpSpPr>
+      <p:grpSpPr/>
+      <p:sp>
+        <p:nvSpPr>
+          <p:cNvPr id="2" name="Title 1"/>
+          <p:cNvSpPr>
+            <a:spLocks noGrp="1"/>
+          </p:cNvSpPr>
+          <p:nvPr>
+            <p:ph type="title"/>
+          </p:nvPr>
+        </p:nvSpPr>
+        <p:spPr/>
+        <p:txBody>
+          <a:bodyPr/>
+          <a:lstStyle/>
+          <a:p>
+            <a:r>
+              <a:rPr sz="3600" b="1" i="0">
+                <a:solidFill>
+                  <a:srgbClr val="102C57"/>
+                </a:solidFill>
+                <a:latin typeface="Calibri"/>
+              </a:rPr>
+              <a:t>Introduction</a:t>
+            </a:r>
+          </a:p>
+        </p:txBody>
+      </p:sp>
+      <p:sp>
+        <p:nvSpPr>
+          <p:cNvPr id="3" name="Content Placeholder 2"/>
+          <p:cNvSpPr>
+            <a:spLocks noGrp="1"/>
+          </p:cNvSpPr>
+          <p:nvPr>
+            <p:ph idx="1"/>
+          </p:nvPr>
+        </p:nvSpPr>
+        <p:spPr/>
+        <p:txBody>
+          <a:bodyPr/>
+          <a:lstStyle/>
+          <a:p/>
+          <a:p>
+            <a:pPr>
+              <a:spcAft>
+                <a:spcPts val="600"/>
+              </a:spcAft>
+            </a:pPr>
+            <a:r>
+              <a:rPr sz="1700" b="1" i="0">
+                <a:solidFill>
+                  <a:srgbClr val="102C57"/>
+                </a:solidFill>
+                <a:latin typeface="Calibri"/>
+              </a:rPr>
+              <a:t>• Online Recruitment Fraud (ORF) Threat: </a:t>
+            </a:r>
+            <a:r>
+              <a:rPr sz="1700" b="0" i="0">
+                <a:solidFill>
+                  <a:srgbClr val="323232"/>
+                </a:solidFill>
+                <a:latin typeface="Calibri"/>
+              </a:rPr>
+              <a:t>Cyber-criminals exploit professional job portals (LinkedIn, Indeed) by posting deceptive employment ads to extort application/visa fees and harvest confidential personal data (PII).</a:t>
+            </a:r>
+          </a:p>
+          <a:p>
+            <a:pPr>
+              <a:spcAft>
+                <a:spcPts val="600"/>
+              </a:spcAft>
+            </a:pPr>
+            <a:r>
+              <a:rPr sz="1700" b="1" i="0">
+                <a:solidFill>
+                  <a:srgbClr val="102C57"/>
+                </a:solidFill>
+                <a:latin typeface="Calibri"/>
+              </a:rPr>
+              <a:t>• Severe Real-World Class Imbalance: </a:t>
+            </a:r>
+            <a:r>
+              <a:rPr sz="1700" b="0" i="0">
+                <a:solidFill>
+                  <a:srgbClr val="323232"/>
+                </a:solidFill>
+                <a:latin typeface="Calibri"/>
+              </a:rPr>
+              <a:t>Genuine postings overwhelmingly dominate online platforms (&gt;95%), creating extreme class sparsity where fake postings account for less than 5% of all advertisements.</a:t>
+            </a:r>
+          </a:p>
+          <a:p>
+            <a:pPr>
+              <a:spcAft>
+                <a:spcPts val="600"/>
+              </a:spcAft>
+            </a:pPr>
+            <a:r>
+              <a:rPr sz="1700" b="1" i="0">
+                <a:solidFill>
+                  <a:srgbClr val="102C57"/>
+                </a:solidFill>
+                <a:latin typeface="Calibri"/>
+              </a:rPr>
+              <a:t>• Limitations of Traditional Machine Learning: </a:t>
+            </a:r>
+            <a:r>
+              <a:rPr sz="1700" b="0" i="0">
+                <a:solidFill>
+                  <a:srgbClr val="323232"/>
+                </a:solidFill>
+                <a:latin typeface="Calibri"/>
+              </a:rPr>
+              <a:t>Conventional algorithms (Logistic Regression, Support Vector Machines, Random Forests) rely on Bag-of-Words (BoW) and TF-IDF vectors, completely ignoring syntactic sentence structure and word order.</a:t>
+            </a:r>
+          </a:p>
+          <a:p>
+            <a:pPr>
+              <a:spcAft>
+                <a:spcPts val="600"/>
+              </a:spcAft>
+            </a:pPr>
+            <a:r>
+              <a:rPr sz="1700" b="1" i="0">
+                <a:solidFill>
+                  <a:srgbClr val="102C57"/>
+                </a:solidFill>
+                <a:latin typeface="Calibri"/>
+              </a:rPr>
+              <a:t>• Deficiencies of Static Word Embeddings: </a:t>
+            </a:r>
+            <a:r>
+              <a:rPr sz="1700" b="0" i="0">
+                <a:solidFill>
+                  <a:srgbClr val="323232"/>
+                </a:solidFill>
+                <a:latin typeface="Calibri"/>
+              </a:rPr>
+              <a:t>Early deep learning approaches (CNNs, standard LSTMs) utilize static embeddings (Word2Vec, GloVe) that assign a single fixed vector per word, failing to handle context-dependent polysemous fraud terms.</a:t>
+            </a:r>
+          </a:p>
+          <a:p>
+            <a:pPr>
+              <a:spcAft>
+                <a:spcPts val="600"/>
+              </a:spcAft>
+            </a:pPr>
+            <a:r>
+              <a:rPr sz="1700" b="1" i="0">
+                <a:solidFill>
+                  <a:srgbClr val="102C57"/>
+                </a:solidFill>
+                <a:latin typeface="Calibri"/>
+              </a:rPr>
+              <a:t>• Motivation for Transformer-Based Architecture: </a:t>
+            </a:r>
+            <a:r>
+              <a:rPr sz="1700" b="0" i="0">
+                <a:solidFill>
+                  <a:srgbClr val="323232"/>
+                </a:solidFill>
+                <a:latin typeface="Calibri"/>
+              </a:rPr>
+              <a:t>Pre-trained Bidirectional Encoder Representations from Transformers (BERT) leverage multi-head self-attention to dynamically capture bidirectional semantic dependencies, dramatically minimizing false positives.</a:t>
+            </a:r>
+          </a:p>
+        </p:txBody>
+      </p:sp>
+      <p:sp>
+        <p:nvSpPr>
+          <p:cNvPr id="4" name="TextBox 3"/>
+          <p:cNvSpPr txBox="1"/>
+          <p:nvPr/>
+        </p:nvSpPr>
+        <p:spPr>
+          <a:xfrm>
+            <a:off x="8613648" y="6355080"/>
+            <a:ext cx="2743200" cy="365760"/>
+          </a:xfrm>
+          <a:prstGeom prst="rect">
+            <a:avLst/>
+          </a:prstGeom>
+          <a:noFill/>
+        </p:spPr>
+        <p:txBody>
+          <a:bodyPr wrap="none">
+            <a:spAutoFit/>
+          </a:bodyPr>
+          <a:lstStyle/>
+          <a:p>
+            <a:pPr algn="r"/>
+            <a:r>
+              <a:rPr sz="1200" b="0" i="0">
+                <a:solidFill>
+                  <a:srgbClr val="787878"/>
+                </a:solidFill>
+                <a:latin typeface="Calibri"/>
+              </a:rPr>
+              <a:t>3</a:t>
+            </a:r>
+          </a:p>
+        </p:txBody>
+      </p:sp>
+    </p:spTree>
+  </p:cSld>
+  <p:clrMapOvr>
+    <a:masterClrMapping/>
+  </p:clrMapOvr>
+</p:sld>
+</file>
+
 <file path=ppt/slides/slide2.xml><?xml version="1.0" encoding="utf-8"?>
 <p:sld xmlns:a="http://schemas.openxmlformats.org/drawingml/2006/main" xmlns:r="http://schemas.openxmlformats.org/officeDocument/2006/relationships" xmlns:p="http://schemas.openxmlformats.org/presentationml/2006/main">
   <p:cSld>
@@ -13675,7 +13906,7 @@
                 </a:solidFill>
                 <a:latin typeface="Calibri"/>
               </a:rPr>
-              <a:t>Presentation Outlines</a:t>
+              <a:t>Table of Contents</a:t>
             </a:r>
           </a:p>
         </p:txBody>
@@ -13705,61 +13936,61 @@
           <a:p>
             <a:pPr>
               <a:spcAft>
-                <a:spcPts val="600"/>
+                <a:spcPts val="500"/>
               </a:spcAft>
             </a:pPr>
             <a:r>
-              <a:rPr sz="1700" b="1" i="0">
+              <a:rPr sz="1600" b="1" i="0">
                 <a:solidFill>
                   <a:srgbClr val="102C57"/>
                 </a:solidFill>
                 <a:latin typeface="Calibri"/>
               </a:rPr>
-              <a:t>1. Research Background &amp; Motivation: </a:t>
-            </a:r>
-            <a:r>
-              <a:rPr sz="1700" b="0" i="0">
+              <a:t>1. Introduction: </a:t>
+            </a:r>
+            <a:r>
+              <a:rPr sz="1600" b="0" i="0">
                 <a:solidFill>
                   <a:srgbClr val="323232"/>
                 </a:solidFill>
                 <a:latin typeface="Calibri"/>
               </a:rPr>
-              <a:t>The menace of Online Recruitment Fraud (ORF) and limitations of traditional static classifiers.</a:t>
+              <a:t>Background on Online Recruitment Fraud (ORF) and challenges in automated scam detection.</a:t>
             </a:r>
           </a:p>
           <a:p>
             <a:pPr>
               <a:spcAft>
-                <a:spcPts val="600"/>
+                <a:spcPts val="500"/>
               </a:spcAft>
             </a:pPr>
             <a:r>
-              <a:rPr sz="1700" b="1" i="0">
+              <a:rPr sz="1600" b="1" i="0">
                 <a:solidFill>
                   <a:srgbClr val="102C57"/>
                 </a:solidFill>
                 <a:latin typeface="Calibri"/>
               </a:rPr>
-              <a:t>2. Review of 5 Benchmark Research Papers: </a:t>
-            </a:r>
-            <a:r>
-              <a:rPr sz="1700" b="0" i="0">
+              <a:t>2. Literature Review: </a:t>
+            </a:r>
+            <a:r>
+              <a:rPr sz="1600" b="0" i="0">
                 <a:solidFill>
                   <a:srgbClr val="323232"/>
                 </a:solidFill>
                 <a:latin typeface="Calibri"/>
               </a:rPr>
-              <a:t>Comparative summary of state-of-the-art literature in fake job detection.</a:t>
+              <a:t>Comparative analysis of 5 landmark research studies in recruitment fraud detection.</a:t>
             </a:r>
           </a:p>
           <a:p>
             <a:pPr>
               <a:spcAft>
-                <a:spcPts val="600"/>
+                <a:spcPts val="500"/>
               </a:spcAft>
             </a:pPr>
             <a:r>
-              <a:rPr sz="1700" b="1" i="0">
+              <a:rPr sz="1600" b="1" i="0">
                 <a:solidFill>
                   <a:srgbClr val="102C57"/>
                 </a:solidFill>
@@ -13768,48 +13999,48 @@
               <a:t>3. Selected Landmark Study (Fraud-BERT): </a:t>
             </a:r>
             <a:r>
-              <a:rPr sz="1700" b="0" i="0">
+              <a:rPr sz="1600" b="0" i="0">
                 <a:solidFill>
                   <a:srgbClr val="323232"/>
                 </a:solidFill>
                 <a:latin typeface="Calibri"/>
               </a:rPr>
-              <a:t>Research objectives, problem formulation, and key contributions by Taneja et al. (2025).</a:t>
+              <a:t>Research problem, scope, and core objectives by Taneja et al. (2025).</a:t>
             </a:r>
           </a:p>
           <a:p>
             <a:pPr>
               <a:spcAft>
-                <a:spcPts val="600"/>
+                <a:spcPts val="500"/>
               </a:spcAft>
             </a:pPr>
             <a:r>
-              <a:rPr sz="1700" b="1" i="0">
+              <a:rPr sz="1600" b="1" i="0">
                 <a:solidFill>
                   <a:srgbClr val="102C57"/>
                 </a:solidFill>
                 <a:latin typeface="Calibri"/>
               </a:rPr>
-              <a:t>4. Machine Learning &amp; Transformer Architecture: </a:t>
-            </a:r>
-            <a:r>
-              <a:rPr sz="1700" b="0" i="0">
+              <a:t>4. Machine Learning Methods &amp; Architecture: </a:t>
+            </a:r>
+            <a:r>
+              <a:rPr sz="1600" b="0" i="0">
                 <a:solidFill>
                   <a:srgbClr val="323232"/>
                 </a:solidFill>
                 <a:latin typeface="Calibri"/>
               </a:rPr>
-              <a:t>Deep bidirectional transformer encoder, multi-head self-attention, and classification head.</a:t>
+              <a:t>BERT transformer architecture, multi-head self-attention, and classification head.</a:t>
             </a:r>
           </a:p>
           <a:p>
             <a:pPr>
               <a:spcAft>
-                <a:spcPts val="600"/>
+                <a:spcPts val="500"/>
               </a:spcAft>
             </a:pPr>
             <a:r>
-              <a:rPr sz="1700" b="1" i="0">
+              <a:rPr sz="1600" b="1" i="0">
                 <a:solidFill>
                   <a:srgbClr val="102C57"/>
                 </a:solidFill>
@@ -13818,23 +14049,23 @@
               <a:t>5. Proposed Prediction Model Pipeline: </a:t>
             </a:r>
             <a:r>
-              <a:rPr sz="1700" b="0" i="0">
+              <a:rPr sz="1600" b="0" i="0">
                 <a:solidFill>
                   <a:srgbClr val="323232"/>
                 </a:solidFill>
                 <a:latin typeface="Calibri"/>
               </a:rPr>
-              <a:t>End-to-end framework from text preprocessing &amp; tokenization to probability inference.</a:t>
+              <a:t>5-stage end-to-end framework from text preprocessing &amp; tokenization to inference.</a:t>
             </a:r>
           </a:p>
           <a:p>
             <a:pPr>
               <a:spcAft>
-                <a:spcPts val="600"/>
+                <a:spcPts val="500"/>
               </a:spcAft>
             </a:pPr>
             <a:r>
-              <a:rPr sz="1700" b="1" i="0">
+              <a:rPr sz="1600" b="1" i="0">
                 <a:solidFill>
                   <a:srgbClr val="102C57"/>
                 </a:solidFill>
@@ -13843,7 +14074,7 @@
               <a:t>6. Dataset &amp; Class Imbalance Analysis: </a:t>
             </a:r>
             <a:r>
-              <a:rPr sz="1700" b="0" i="0">
+              <a:rPr sz="1600" b="0" i="0">
                 <a:solidFill>
                   <a:srgbClr val="323232"/>
                 </a:solidFill>
@@ -13855,51 +14086,51 @@
           <a:p>
             <a:pPr>
               <a:spcAft>
-                <a:spcPts val="600"/>
+                <a:spcPts val="500"/>
               </a:spcAft>
             </a:pPr>
             <a:r>
-              <a:rPr sz="1700" b="1" i="0">
+              <a:rPr sz="1600" b="1" i="0">
                 <a:solidFill>
                   <a:srgbClr val="102C57"/>
                 </a:solidFill>
                 <a:latin typeface="Calibri"/>
               </a:rPr>
-              <a:t>7. Experimental Results &amp; Comparative Analysis: </a:t>
-            </a:r>
-            <a:r>
-              <a:rPr sz="1700" b="0" i="0">
+              <a:t>7. Results &amp; Comparative Performance: </a:t>
+            </a:r>
+            <a:r>
+              <a:rPr sz="1600" b="0" i="0">
                 <a:solidFill>
                   <a:srgbClr val="323232"/>
                 </a:solidFill>
                 <a:latin typeface="Calibri"/>
               </a:rPr>
-              <a:t>Performance metrics (Accuracy, Macro F1, Recall, ROC-AUC) versus baseline models.</a:t>
+              <a:t>Empirical performance evaluation (Accuracy, Macro F1, Recall, ROC-AUC) against baselines.</a:t>
             </a:r>
           </a:p>
           <a:p>
             <a:pPr>
               <a:spcAft>
-                <a:spcPts val="600"/>
+                <a:spcPts val="500"/>
               </a:spcAft>
             </a:pPr>
             <a:r>
-              <a:rPr sz="1700" b="1" i="0">
+              <a:rPr sz="1600" b="1" i="0">
                 <a:solidFill>
                   <a:srgbClr val="102C57"/>
                 </a:solidFill>
                 <a:latin typeface="Calibri"/>
               </a:rPr>
-              <a:t>8. Key References: </a:t>
-            </a:r>
-            <a:r>
-              <a:rPr sz="1700" b="0" i="0">
+              <a:t>8. Bibliography or References: </a:t>
+            </a:r>
+            <a:r>
+              <a:rPr sz="1600" b="0" i="0">
                 <a:solidFill>
                   <a:srgbClr val="323232"/>
                 </a:solidFill>
                 <a:latin typeface="Calibri"/>
               </a:rPr>
-              <a:t>Bibliographic citations of all 5 reviewed studies in standard APA 7th edition format.</a:t>
+              <a:t>Complete bibliographic citations of the 5 reviewed studies in standard APA 7th edition format.</a:t>
             </a:r>
           </a:p>
         </p:txBody>
@@ -13919,12 +14150,16 @@
           <a:bodyPr/>
           <a:lstStyle/>
           <a:p>
-            <a:fld id="{BDCDBBEF-AA6C-4BA6-85B2-A17D7F280E38}" type="slidenum">
-              <a:rPr lang="en-US" smtClean="0"/>
-              <a:pPr/>
+            <a:pPr algn="r"/>
+            <a:r>
+              <a:rPr sz="1200" b="0" i="0">
+                <a:solidFill>
+                  <a:srgbClr val="787878"/>
+                </a:solidFill>
+                <a:latin typeface="Calibri"/>
+              </a:rPr>
               <a:t>2</a:t>
-            </a:fld>
-            <a:endParaRPr lang="en-US" dirty="0"/>
+            </a:r>
           </a:p>
         </p:txBody>
       </p:sp>
@@ -13999,7 +14234,7 @@
                 </a:solidFill>
                 <a:latin typeface="Calibri"/>
               </a:rPr>
-              <a:t>Related Five-Research Paper</a:t>
+              <a:t>Literature Review</a:t>
             </a:r>
           </a:p>
         </p:txBody>
@@ -14019,12 +14254,16 @@
           <a:bodyPr/>
           <a:lstStyle/>
           <a:p>
-            <a:fld id="{BDCDBBEF-AA6C-4BA6-85B2-A17D7F280E38}" type="slidenum">
-              <a:rPr lang="en-US" smtClean="0"/>
-              <a:pPr/>
-              <a:t>3</a:t>
-            </a:fld>
-            <a:endParaRPr lang="en-US" dirty="0"/>
+            <a:pPr algn="r"/>
+            <a:r>
+              <a:rPr sz="1200" b="0" i="0">
+                <a:solidFill>
+                  <a:srgbClr val="787878"/>
+                </a:solidFill>
+                <a:latin typeface="Calibri"/>
+              </a:rPr>
+              <a:t>4</a:t>
+            </a:r>
           </a:p>
         </p:txBody>
       </p:sp>
@@ -14140,7 +14379,7 @@
                           </a:solidFill>
                           <a:latin typeface="Calibri"/>
                         </a:rPr>
-                        <a:t>Authors</a:t>
+                        <a:t>Authors &amp; Year</a:t>
                       </a:r>
                     </a:p>
                   </a:txBody>
@@ -14223,7 +14462,7 @@
                           </a:solidFill>
                           <a:latin typeface="Calibri"/>
                         </a:rPr>
-                        <a:t>K. Taneja, J. Vashishtha, S. Ratnoo</a:t>
+                        <a:t>K. Taneja, J. Vashishtha, S. Ratnoo (2025)</a:t>
                       </a:r>
                     </a:p>
                   </a:txBody>
@@ -14306,7 +14545,7 @@
                           </a:solidFill>
                           <a:latin typeface="Calibri"/>
                         </a:rPr>
-                        <a:t>A. S. Pillai</a:t>
+                        <a:t>A. S. Pillai (2023)</a:t>
                       </a:r>
                     </a:p>
                   </a:txBody>
@@ -14389,7 +14628,7 @@
                           </a:solidFill>
                           <a:latin typeface="Calibri"/>
                         </a:rPr>
-                        <a:t>M. Naudé, K. J. Adebayo, R. Nanda</a:t>
+                        <a:t>M. Naudé, K. J. Adebayo, R. Nanda (2023)</a:t>
                       </a:r>
                     </a:p>
                   </a:txBody>
@@ -14472,7 +14711,7 @@
                           </a:solidFill>
                           <a:latin typeface="Calibri"/>
                         </a:rPr>
-                        <a:t>B. Chiraratanasopha, T. Chay-intr</a:t>
+                        <a:t>B. Chiraratanasopha, T. Chay-intr (2022)</a:t>
                       </a:r>
                     </a:p>
                   </a:txBody>
@@ -14555,7 +14794,7 @@
                           </a:solidFill>
                           <a:latin typeface="Calibri"/>
                         </a:rPr>
-                        <a:t>G. Varshitha, K. Sowmya, K. Sheshma</a:t>
+                        <a:t>G. Varshitha, K. Sowmya, K. Sheshma (2026)</a:t>
                       </a:r>
                     </a:p>
                   </a:txBody>
@@ -14666,11 +14905,6 @@
           </a:p>
           <a:p>
             <a:r>
-              <a:t>DOI: 10.1007/s44425-025-00109-x</a:t>
-            </a:r>
-          </a:p>
-          <a:p>
-            <a:r>
               <a:rPr sz="1600" b="0" i="1">
                 <a:solidFill>
                   <a:srgbClr val="0066CC"/>
@@ -14810,12 +15044,16 @@
           <a:bodyPr/>
           <a:lstStyle/>
           <a:p>
-            <a:fld id="{BDCDBBEF-AA6C-4BA6-85B2-A17D7F280E38}" type="slidenum">
-              <a:rPr lang="en-US" smtClean="0"/>
-              <a:pPr/>
-              <a:t>4</a:t>
-            </a:fld>
-            <a:endParaRPr lang="en-US" dirty="0"/>
+            <a:pPr algn="r"/>
+            <a:r>
+              <a:rPr sz="1200" b="0" i="0">
+                <a:solidFill>
+                  <a:srgbClr val="787878"/>
+                </a:solidFill>
+                <a:latin typeface="Calibri"/>
+              </a:rPr>
+              <a:t>5</a:t>
+            </a:r>
           </a:p>
         </p:txBody>
       </p:sp>
@@ -15154,12 +15392,16 @@
           <a:bodyPr/>
           <a:lstStyle/>
           <a:p>
-            <a:fld id="{BDCDBBEF-AA6C-4BA6-85B2-A17D7F280E38}" type="slidenum">
-              <a:rPr lang="en-US" smtClean="0"/>
-              <a:pPr/>
-              <a:t>5</a:t>
-            </a:fld>
-            <a:endParaRPr lang="en-US" dirty="0"/>
+            <a:pPr algn="r"/>
+            <a:r>
+              <a:rPr sz="1200" b="0" i="0">
+                <a:solidFill>
+                  <a:srgbClr val="787878"/>
+                </a:solidFill>
+                <a:latin typeface="Calibri"/>
+              </a:rPr>
+              <a:t>6</a:t>
+            </a:r>
           </a:p>
         </p:txBody>
       </p:sp>
@@ -15414,12 +15656,16 @@
           <a:bodyPr/>
           <a:lstStyle/>
           <a:p>
-            <a:fld id="{BDCDBBEF-AA6C-4BA6-85B2-A17D7F280E38}" type="slidenum">
-              <a:rPr lang="en-US" smtClean="0"/>
-              <a:pPr/>
-              <a:t>6</a:t>
-            </a:fld>
-            <a:endParaRPr lang="en-US" dirty="0"/>
+            <a:pPr algn="r"/>
+            <a:r>
+              <a:rPr sz="1200" b="0" i="0">
+                <a:solidFill>
+                  <a:srgbClr val="787878"/>
+                </a:solidFill>
+                <a:latin typeface="Calibri"/>
+              </a:rPr>
+              <a:t>7</a:t>
+            </a:r>
           </a:p>
         </p:txBody>
       </p:sp>
@@ -15514,12 +15760,16 @@
           <a:bodyPr/>
           <a:lstStyle/>
           <a:p>
-            <a:fld id="{BDCDBBEF-AA6C-4BA6-85B2-A17D7F280E38}" type="slidenum">
-              <a:rPr lang="en-US" smtClean="0"/>
-              <a:pPr/>
-              <a:t>7</a:t>
-            </a:fld>
-            <a:endParaRPr lang="en-US" dirty="0"/>
+            <a:pPr algn="r"/>
+            <a:r>
+              <a:rPr sz="1200" b="0" i="0">
+                <a:solidFill>
+                  <a:srgbClr val="787878"/>
+                </a:solidFill>
+                <a:latin typeface="Calibri"/>
+              </a:rPr>
+              <a:t>8</a:t>
+            </a:r>
           </a:p>
         </p:txBody>
       </p:sp>
@@ -16071,12 +16321,16 @@
           <a:bodyPr/>
           <a:lstStyle/>
           <a:p>
-            <a:fld id="{BDCDBBEF-AA6C-4BA6-85B2-A17D7F280E38}" type="slidenum">
-              <a:rPr lang="en-US" smtClean="0"/>
-              <a:pPr/>
-              <a:t>8</a:t>
-            </a:fld>
-            <a:endParaRPr lang="en-US" dirty="0"/>
+            <a:pPr algn="r"/>
+            <a:r>
+              <a:rPr sz="1200" b="0" i="0">
+                <a:solidFill>
+                  <a:srgbClr val="787878"/>
+                </a:solidFill>
+                <a:latin typeface="Calibri"/>
+              </a:rPr>
+              <a:t>9</a:t>
+            </a:r>
           </a:p>
         </p:txBody>
       </p:sp>
@@ -16157,7 +16411,7 @@
                 </a:solidFill>
                 <a:latin typeface="Calibri"/>
               </a:rPr>
-              <a:t>References (APA 7th Edition)</a:t>
+              <a:t>Bibliography or References</a:t>
             </a:r>
           </a:p>
         </p:txBody>
@@ -16200,16 +16454,16 @@
               </a:spcAft>
             </a:pPr>
             <a:r>
-              <a:rPr sz="1400" b="1" i="0">
+              <a:rPr sz="1300" b="1" i="0">
                 <a:solidFill>
                   <a:srgbClr val="102C57"/>
                 </a:solidFill>
                 <a:latin typeface="Calibri"/>
               </a:rPr>
-              <a:t>1. </a:t>
-            </a:r>
-            <a:r>
-              <a:rPr sz="1400" b="0" i="0">
+              <a:t>[1] </a:t>
+            </a:r>
+            <a:r>
+              <a:rPr sz="1300" b="0" i="0">
                 <a:solidFill>
                   <a:srgbClr val="323232"/>
                 </a:solidFill>
@@ -16218,7 +16472,7 @@
               <a:t>Taneja, K., Vashishtha, J., &amp; Ratnoo, S. (2025). Fraud-BERT: Transformer based context aware online recruitment fraud detection. </a:t>
             </a:r>
             <a:r>
-              <a:rPr sz="1400" b="0" i="1">
+              <a:rPr sz="1300" b="0" i="1">
                 <a:solidFill>
                   <a:srgbClr val="323232"/>
                 </a:solidFill>
@@ -16227,7 +16481,7 @@
               <a:t>Discover Computing</a:t>
             </a:r>
             <a:r>
-              <a:rPr sz="1400" b="0" i="0">
+              <a:rPr sz="1300" b="0" i="0">
                 <a:solidFill>
                   <a:srgbClr val="323232"/>
                 </a:solidFill>
@@ -16236,7 +16490,7 @@
               <a:t>, </a:t>
             </a:r>
             <a:r>
-              <a:rPr sz="1400" b="0" i="1">
+              <a:rPr sz="1300" b="0" i="1">
                 <a:solidFill>
                   <a:srgbClr val="323232"/>
                 </a:solidFill>
@@ -16245,7 +16499,7 @@
               <a:t>28</a:t>
             </a:r>
             <a:r>
-              <a:rPr sz="1400" b="0" i="0">
+              <a:rPr sz="1300" b="0" i="0">
                 <a:solidFill>
                   <a:srgbClr val="323232"/>
                 </a:solidFill>
@@ -16254,7 +16508,7 @@
               <a:t>(9), 1–16.</a:t>
             </a:r>
             <a:r>
-              <a:rPr sz="1300" b="0" i="0">
+              <a:rPr sz="1200" b="0" i="0">
                 <a:solidFill>
                   <a:srgbClr val="0066CC"/>
                 </a:solidFill>
@@ -16273,16 +16527,16 @@
               </a:spcAft>
             </a:pPr>
             <a:r>
-              <a:rPr sz="1400" b="1" i="0">
+              <a:rPr sz="1300" b="1" i="0">
                 <a:solidFill>
                   <a:srgbClr val="102C57"/>
                 </a:solidFill>
                 <a:latin typeface="Calibri"/>
               </a:rPr>
-              <a:t>2. </a:t>
-            </a:r>
-            <a:r>
-              <a:rPr sz="1400" b="0" i="0">
+              <a:t>[2] </a:t>
+            </a:r>
+            <a:r>
+              <a:rPr sz="1300" b="0" i="0">
                 <a:solidFill>
                   <a:srgbClr val="323232"/>
                 </a:solidFill>
@@ -16291,7 +16545,7 @@
               <a:t>Pillai, A. S. (2023). Detecting fake job postings using bidirectional LSTM. </a:t>
             </a:r>
             <a:r>
-              <a:rPr sz="1400" b="0" i="1">
+              <a:rPr sz="1300" b="0" i="1">
                 <a:solidFill>
                   <a:srgbClr val="323232"/>
                 </a:solidFill>
@@ -16300,7 +16554,7 @@
               <a:t>International Research Journal of Modernization in Engineering Technology and Science</a:t>
             </a:r>
             <a:r>
-              <a:rPr sz="1400" b="0" i="0">
+              <a:rPr sz="1300" b="0" i="0">
                 <a:solidFill>
                   <a:srgbClr val="323232"/>
                 </a:solidFill>
@@ -16309,7 +16563,7 @@
               <a:t>, </a:t>
             </a:r>
             <a:r>
-              <a:rPr sz="1400" b="0" i="1">
+              <a:rPr sz="1300" b="0" i="1">
                 <a:solidFill>
                   <a:srgbClr val="323232"/>
                 </a:solidFill>
@@ -16318,7 +16572,7 @@
               <a:t>5</a:t>
             </a:r>
             <a:r>
-              <a:rPr sz="1400" b="0" i="0">
+              <a:rPr sz="1300" b="0" i="0">
                 <a:solidFill>
                   <a:srgbClr val="323232"/>
                 </a:solidFill>
@@ -16327,7 +16581,7 @@
               <a:t>(3), 3883–3890.</a:t>
             </a:r>
             <a:r>
-              <a:rPr sz="1300" b="0" i="0">
+              <a:rPr sz="1200" b="0" i="0">
                 <a:solidFill>
                   <a:srgbClr val="0066CC"/>
                 </a:solidFill>
@@ -16346,16 +16600,16 @@
               </a:spcAft>
             </a:pPr>
             <a:r>
-              <a:rPr sz="1400" b="1" i="0">
+              <a:rPr sz="1300" b="1" i="0">
                 <a:solidFill>
                   <a:srgbClr val="102C57"/>
                 </a:solidFill>
                 <a:latin typeface="Calibri"/>
               </a:rPr>
-              <a:t>3. </a:t>
-            </a:r>
-            <a:r>
-              <a:rPr sz="1400" b="0" i="0">
+              <a:t>[3] </a:t>
+            </a:r>
+            <a:r>
+              <a:rPr sz="1300" b="0" i="0">
                 <a:solidFill>
                   <a:srgbClr val="323232"/>
                 </a:solidFill>
@@ -16364,7 +16618,7 @@
               <a:t>Naudé, M., Adebayo, K. J., &amp; Nanda, R. (2023). A machine learning approach to detecting fraudulent job types. </a:t>
             </a:r>
             <a:r>
-              <a:rPr sz="1400" b="0" i="1">
+              <a:rPr sz="1300" b="0" i="1">
                 <a:solidFill>
                   <a:srgbClr val="323232"/>
                 </a:solidFill>
@@ -16373,7 +16627,7 @@
               <a:t>AI &amp; SOCIETY</a:t>
             </a:r>
             <a:r>
-              <a:rPr sz="1400" b="0" i="0">
+              <a:rPr sz="1300" b="0" i="0">
                 <a:solidFill>
                   <a:srgbClr val="323232"/>
                 </a:solidFill>
@@ -16382,7 +16636,7 @@
               <a:t>, </a:t>
             </a:r>
             <a:r>
-              <a:rPr sz="1400" b="0" i="1">
+              <a:rPr sz="1300" b="0" i="1">
                 <a:solidFill>
                   <a:srgbClr val="323232"/>
                 </a:solidFill>
@@ -16391,7 +16645,7 @@
               <a:t>38</a:t>
             </a:r>
             <a:r>
-              <a:rPr sz="1400" b="0" i="0">
+              <a:rPr sz="1300" b="0" i="0">
                 <a:solidFill>
                   <a:srgbClr val="323232"/>
                 </a:solidFill>
@@ -16400,7 +16654,7 @@
               <a:t>(3), 1013–1024.</a:t>
             </a:r>
             <a:r>
-              <a:rPr sz="1300" b="0" i="0">
+              <a:rPr sz="1200" b="0" i="0">
                 <a:solidFill>
                   <a:srgbClr val="0066CC"/>
                 </a:solidFill>
@@ -16419,16 +16673,16 @@
               </a:spcAft>
             </a:pPr>
             <a:r>
-              <a:rPr sz="1400" b="1" i="0">
+              <a:rPr sz="1300" b="1" i="0">
                 <a:solidFill>
                   <a:srgbClr val="102C57"/>
                 </a:solidFill>
                 <a:latin typeface="Calibri"/>
               </a:rPr>
-              <a:t>4. </a:t>
-            </a:r>
-            <a:r>
-              <a:rPr sz="1400" b="0" i="0">
+              <a:t>[4] </a:t>
+            </a:r>
+            <a:r>
+              <a:rPr sz="1300" b="0" i="0">
                 <a:solidFill>
                   <a:srgbClr val="323232"/>
                 </a:solidFill>
@@ -16437,7 +16691,7 @@
               <a:t>Chiraratanasopha, B., &amp; Chay-intr, T. (2022). Detecting fraud job recruitment using features reflecting from real-world knowledge of fraud. </a:t>
             </a:r>
             <a:r>
-              <a:rPr sz="1400" b="0" i="1">
+              <a:rPr sz="1300" b="0" i="1">
                 <a:solidFill>
                   <a:srgbClr val="323232"/>
                 </a:solidFill>
@@ -16446,7 +16700,7 @@
               <a:t>Current Applied Science and Technology</a:t>
             </a:r>
             <a:r>
-              <a:rPr sz="1400" b="0" i="0">
+              <a:rPr sz="1300" b="0" i="0">
                 <a:solidFill>
                   <a:srgbClr val="323232"/>
                 </a:solidFill>
@@ -16455,7 +16709,7 @@
               <a:t>, </a:t>
             </a:r>
             <a:r>
-              <a:rPr sz="1400" b="0" i="1">
+              <a:rPr sz="1300" b="0" i="1">
                 <a:solidFill>
                   <a:srgbClr val="323232"/>
                 </a:solidFill>
@@ -16464,7 +16718,7 @@
               <a:t>22</a:t>
             </a:r>
             <a:r>
-              <a:rPr sz="1400" b="0" i="0">
+              <a:rPr sz="1300" b="0" i="0">
                 <a:solidFill>
                   <a:srgbClr val="323232"/>
                 </a:solidFill>
@@ -16473,7 +16727,7 @@
               <a:t>(6), 1–12.</a:t>
             </a:r>
             <a:r>
-              <a:rPr sz="1300" b="0" i="0">
+              <a:rPr sz="1200" b="0" i="0">
                 <a:solidFill>
                   <a:srgbClr val="0066CC"/>
                 </a:solidFill>
@@ -16492,16 +16746,16 @@
               </a:spcAft>
             </a:pPr>
             <a:r>
-              <a:rPr sz="1400" b="1" i="0">
+              <a:rPr sz="1300" b="1" i="0">
                 <a:solidFill>
                   <a:srgbClr val="102C57"/>
                 </a:solidFill>
                 <a:latin typeface="Calibri"/>
               </a:rPr>
-              <a:t>5. </a:t>
-            </a:r>
-            <a:r>
-              <a:rPr sz="1400" b="0" i="0">
+              <a:t>[5] </a:t>
+            </a:r>
+            <a:r>
+              <a:rPr sz="1300" b="0" i="0">
                 <a:solidFill>
                   <a:srgbClr val="323232"/>
                 </a:solidFill>
@@ -16510,7 +16764,7 @@
               <a:t>Varshitha, G., Sowmya, K., Sheshma, K., Sowmya, K., &amp; Manikandan, R. A. (2026). Online recruitment fraud detection using deep learning approaches. </a:t>
             </a:r>
             <a:r>
-              <a:rPr sz="1400" b="0" i="1">
+              <a:rPr sz="1300" b="0" i="1">
                 <a:solidFill>
                   <a:srgbClr val="323232"/>
                 </a:solidFill>
@@ -16519,7 +16773,7 @@
               <a:t>International Journal for Multidisciplinary Research (IJFMR)</a:t>
             </a:r>
             <a:r>
-              <a:rPr sz="1400" b="0" i="0">
+              <a:rPr sz="1300" b="0" i="0">
                 <a:solidFill>
                   <a:srgbClr val="323232"/>
                 </a:solidFill>
@@ -16528,7 +16782,7 @@
               <a:t>, </a:t>
             </a:r>
             <a:r>
-              <a:rPr sz="1400" b="0" i="1">
+              <a:rPr sz="1300" b="0" i="1">
                 <a:solidFill>
                   <a:srgbClr val="323232"/>
                 </a:solidFill>
@@ -16537,7 +16791,7 @@
               <a:t>8</a:t>
             </a:r>
             <a:r>
-              <a:rPr sz="1400" b="0" i="0">
+              <a:rPr sz="1300" b="0" i="0">
                 <a:solidFill>
                   <a:srgbClr val="323232"/>
                 </a:solidFill>
@@ -16546,7 +16800,7 @@
               <a:t>(2), 1–9.</a:t>
             </a:r>
             <a:r>
-              <a:rPr sz="1300" b="0" i="0">
+              <a:rPr sz="1200" b="0" i="0">
                 <a:solidFill>
                   <a:srgbClr val="0066CC"/>
                 </a:solidFill>
@@ -16578,12 +16832,16 @@
           <a:bodyPr/>
           <a:lstStyle/>
           <a:p>
-            <a:fld id="{BDCDBBEF-AA6C-4BA6-85B2-A17D7F280E38}" type="slidenum">
-              <a:rPr lang="en-US" smtClean="0"/>
-              <a:pPr/>
-              <a:t>9</a:t>
-            </a:fld>
-            <a:endParaRPr lang="en-US" dirty="0"/>
+            <a:pPr algn="r"/>
+            <a:r>
+              <a:rPr sz="1200" b="0" i="0">
+                <a:solidFill>
+                  <a:srgbClr val="787878"/>
+                </a:solidFill>
+                <a:latin typeface="Calibri"/>
+              </a:rPr>
+              <a:t>10</a:t>
+            </a:r>
           </a:p>
         </p:txBody>
       </p:sp>

</xml_diff>